<commit_message>
feat: production-readiness Presentation Workspace, rehearsal review and decisions
Snapshot of in-progress production-readiness work: Presentation Workspace
editing (tables, charts, shapes, text fit, revisions, assets), rehearsal
coverage/objection review with GUI workflow, fast decisions, ChatGPT-plan
auth groundwork, objection equivalence provider contract, fidelity corpus
tooling and accompanying tests/docs.

Co-Authored-By: Claude Opus 5.5 <noreply@anthropic.com>
</commit_message>
<xml_diff>
--- a/samples/synthetic-deck/deck/presentation.pptx
+++ b/samples/synthetic-deck/deck/presentation.pptx
@@ -5015,6 +5015,9 @@
           <a:lstStyle/>
           <a:p>
             <a:r>
+              <a:rPr>
+                <a:latin typeface="Presenter Copilot Missing Font Smoke"/>
+              </a:rPr>
               <a:t>Northstar migration decision</a:t>
             </a:r>
           </a:p>
@@ -5052,6 +5055,75 @@
           </a:p>
         </p:txBody>
       </p:sp>
+      <p:sp>
+        <p:nvSpPr>
+          <p:cNvPr id="4" name="Workspace transform test shape"/>
+          <p:cNvSpPr/>
+          <p:nvPr/>
+        </p:nvSpPr>
+        <p:spPr>
+          <a:xfrm>
+            <a:off x="7315200" y="5715000"/>
+            <a:ext cx="1371600" cy="457200"/>
+          </a:xfrm>
+          <a:prstGeom prst="rect">
+            <a:avLst/>
+          </a:prstGeom>
+          <a:solidFill>
+            <a:srgbClr val="E0EDFA"/>
+          </a:solidFill>
+          <a:ln>
+            <a:solidFill>
+              <a:srgbClr val="396EA7"/>
+            </a:solidFill>
+          </a:ln>
+        </p:spPr>
+        <p:style>
+          <a:lnRef idx="1">
+            <a:schemeClr val="accent1"/>
+          </a:lnRef>
+          <a:fillRef idx="3">
+            <a:schemeClr val="accent1"/>
+          </a:fillRef>
+          <a:effectRef idx="2">
+            <a:schemeClr val="accent1"/>
+          </a:effectRef>
+          <a:fontRef idx="minor">
+            <a:schemeClr val="lt1"/>
+          </a:fontRef>
+        </p:style>
+        <p:txBody>
+          <a:bodyPr rtlCol="0" anchor="ctr"/>
+          <a:lstStyle/>
+          <a:p>
+            <a:pPr algn="ctr"/>
+          </a:p>
+        </p:txBody>
+      </p:sp>
+      <p:pic>
+        <p:nvPicPr>
+          <p:cNvPr id="5" name="Workspace duplicate test picture" descr="Synthetic picture used to exercise picture editing."/>
+          <p:cNvPicPr>
+            <a:picLocks noChangeAspect="1"/>
+          </p:cNvPicPr>
+          <p:nvPr/>
+        </p:nvPicPr>
+        <p:blipFill>
+          <a:blip r:embed="rId3"/>
+          <a:stretch>
+            <a:fillRect/>
+          </a:stretch>
+        </p:blipFill>
+        <p:spPr>
+          <a:xfrm>
+            <a:off x="5257800" y="5486400"/>
+            <a:ext cx="1600200" cy="1028700"/>
+          </a:xfrm>
+          <a:prstGeom prst="rect">
+            <a:avLst/>
+          </a:prstGeom>
+        </p:spPr>
+      </p:pic>
     </p:spTree>
   </p:cSld>
   <p:clrMapOvr>
@@ -5803,12 +5875,12 @@
       </p:sp>
       <p:sp>
         <p:nvSpPr>
-          <p:cNvPr id="3" name="Content Placeholder 2"/>
-          <p:cNvSpPr>
-            <a:spLocks noGrp="1"/>
-          </p:cNvSpPr>
-          <p:nvPr>
-            <p:ph idx="1"/>
+          <p:cNvPr id="3" name="Text Placeholder 2"/>
+          <p:cNvSpPr>
+            <a:spLocks noGrp="1"/>
+          </p:cNvSpPr>
+          <p:nvPr>
+            <p:ph type="body" idx="1"/>
           </p:nvPr>
         </p:nvSpPr>
         <p:spPr/>

</xml_diff>